<commit_message>
fix(pitch): slide 8 card overlap and slide 19 table wrap
Slide 8: dropped the redundant fourth right-column card (folded its point
into the left card's bullet list, which also removes the empty band there)
and evenly spaced the remaining three cards across the full column height.
Slide 19: widened the Target column (1.5/1.3/0.8in), shortened cell text to
fit two lines, and removed the misleading "Tests passing (÷400)" chart bar —
the 347/399 count with 47 Postgres-gated skips isn't a ratio against a
target; it stays in the KPI table row instead.
</commit_message>
<xml_diff>
--- a/docs/pitch/harbormaster-architecture-deck.pptx
+++ b/docs/pitch/harbormaster-architecture-deck.pptx
@@ -220,9 +220,9 @@
           </c:dLbls>
           <c:cat>
             <c:multiLvlStrRef>
-              <c:f>Sheet1!$A$2:$A$6</c:f>
+              <c:f>Sheet1!$A$2:$A$5</c:f>
               <c:multiLvlStrCache>
-                <c:ptCount val="5"/>
+                <c:ptCount val="4"/>
                 <c:lvl>
                   <c:pt idx="0">
                     <c:v>Field-mapping accuracy</c:v>
@@ -236,19 +236,16 @@
                   <c:pt idx="3">
                     <c:v>Quarantine recall</c:v>
                   </c:pt>
-                  <c:pt idx="4">
-                    <c:v>Tests passing (÷400)</c:v>
-                  </c:pt>
                 </c:lvl>
               </c:multiLvlStrCache>
             </c:multiLvlStrRef>
           </c:cat>
           <c:val>
             <c:numRef>
-              <c:f>Sheet1!$B$2:$B$6</c:f>
+              <c:f>Sheet1!$B$2:$B$5</c:f>
               <c:numCache>
                 <c:formatCode>General</c:formatCode>
-                <c:ptCount val="5"/>
+                <c:ptCount val="4"/>
                 <c:pt idx="0">
                   <c:v>0.977</c:v>
                 </c:pt>
@@ -260,9 +257,6 @@
                 </c:pt>
                 <c:pt idx="3">
                   <c:v>0.667</c:v>
-                </c:pt>
-                <c:pt idx="4">
-                  <c:v>0.87</c:v>
                 </c:pt>
               </c:numCache>
             </c:numRef>
@@ -11061,9 +11055,9 @@
             <a:tbl>
               <a:tblPr/>
               <a:tblGrid>
-                <a:gridCol w="1737360"/>
-                <a:gridCol w="1005840"/>
-                <a:gridCol w="548640"/>
+                <a:gridCol w="1371600"/>
+                <a:gridCol w="1188720"/>
+                <a:gridCol w="731520"/>
               </a:tblGrid>
               <a:tr h="0">
                 <a:tc>
@@ -11354,7 +11348,7 @@
                           <a:ea typeface="Calibri" pitchFamily="34" charset="-122"/>
                           <a:cs typeface="Calibri" pitchFamily="34" charset="-120"/>
                         </a:rPr>
-                        <a:t>97.7% (209/214 columns, 19 files)</a:t>
+                        <a:t>97.7% (209/214, 19 files)</a:t>
                       </a:r>
                       <a:endParaRPr lang="en-US" sz="750" dirty="0">
                         <a:latin typeface="Calibri" charset="0"/>
@@ -11419,7 +11413,7 @@
                           <a:ea typeface="Calibri" pitchFamily="34" charset="-122"/>
                           <a:cs typeface="Calibri" pitchFamily="34" charset="-120"/>
                         </a:rPr>
-                        <a:t>n/a, headline</a:t>
+                        <a:t>headline</a:t>
                       </a:r>
                       <a:endParaRPr lang="en-US" sz="750" dirty="0">
                         <a:latin typeface="Calibri" charset="0"/>
@@ -11616,7 +11610,7 @@
                           <a:ea typeface="Calibri" pitchFamily="34" charset="-122"/>
                           <a:cs typeface="Calibri" pitchFamily="34" charset="-120"/>
                         </a:rPr>
-                        <a:t>n/a, headline</a:t>
+                        <a:t>headline</a:t>
                       </a:r>
                       <a:endParaRPr lang="en-US" sz="750" dirty="0">
                         <a:latin typeface="Calibri" charset="0"/>
@@ -11748,7 +11742,7 @@
                           <a:ea typeface="Calibri" pitchFamily="34" charset="-122"/>
                           <a:cs typeface="Calibri" pitchFamily="34" charset="-120"/>
                         </a:rPr>
-                        <a:t>41 (18 adjudication calls)</a:t>
+                        <a:t>41 (18 calls)</a:t>
                       </a:r>
                       <a:endParaRPr lang="en-US" sz="750" dirty="0">
                         <a:latin typeface="Calibri" charset="0"/>
@@ -11813,7 +11807,7 @@
                           <a:ea typeface="Calibri" pitchFamily="34" charset="-122"/>
                           <a:cs typeface="Calibri" pitchFamily="34" charset="-120"/>
                         </a:rPr>
-                        <a:t>≤2% once warm (NFR-8)</a:t>
+                        <a:t>≤2% warm (NFR-8)</a:t>
                       </a:r>
                       <a:endParaRPr lang="en-US" sz="750" dirty="0">
                         <a:latin typeface="Calibri" charset="0"/>
@@ -12010,7 +12004,7 @@
                           <a:ea typeface="Calibri" pitchFamily="34" charset="-122"/>
                           <a:cs typeface="Calibri" pitchFamily="34" charset="-120"/>
                         </a:rPr>
-                        <a:t>n/a; recall is an honest miss</a:t>
+                        <a:t>honest miss</a:t>
                       </a:r>
                       <a:endParaRPr lang="en-US" sz="750" dirty="0">
                         <a:latin typeface="Calibri" charset="0"/>
@@ -12339,7 +12333,7 @@
                           <a:ea typeface="Calibri" pitchFamily="34" charset="-122"/>
                           <a:cs typeface="Calibri" pitchFamily="34" charset="-120"/>
                         </a:rPr>
-                        <a:t>347 passed / 399 collected, 0 failed</a:t>
+                        <a:t>347 passed, 47 skipped without Postgres, 0 failed</a:t>
                       </a:r>
                       <a:endParaRPr lang="en-US" sz="750" dirty="0">
                         <a:latin typeface="Calibri" charset="0"/>
@@ -12404,7 +12398,7 @@
                           <a:ea typeface="Calibri" pitchFamily="34" charset="-122"/>
                           <a:cs typeface="Calibri" pitchFamily="34" charset="-120"/>
                         </a:rPr>
-                        <a:t>offline, no network</a:t>
+                        <a:t>offline, no net</a:t>
                       </a:r>
                       <a:endParaRPr lang="en-US" sz="750" dirty="0">
                         <a:latin typeface="Calibri" charset="0"/>
@@ -27944,8 +27938,8 @@
         </p:nvSpPr>
         <p:spPr>
           <a:xfrm>
-            <a:off x="594360" y="3200400"/>
-            <a:ext cx="3931920" cy="1188720"/>
+            <a:off x="594360" y="2788920"/>
+            <a:ext cx="3931920" cy="1554480"/>
           </a:xfrm>
           <a:prstGeom prst="rect">
             <a:avLst/>
@@ -28019,6 +28013,27 @@
             </a:r>
             <a:endParaRPr lang="en-US" sz="900" dirty="0"/>
           </a:p>
+          <a:p>
+            <a:pPr marL="342900" indent="-342900">
+              <a:spcAft>
+                <a:spcPts val="400"/>
+              </a:spcAft>
+              <a:buSzPct val="100000"/>
+              <a:buChar char="•"/>
+            </a:pPr>
+            <a:r>
+              <a:rPr lang="en-US" sz="900" dirty="0">
+                <a:solidFill>
+                  <a:srgbClr val="DCE7F5"/>
+                </a:solidFill>
+                <a:latin typeface="Calibri" pitchFamily="34" charset="0"/>
+                <a:ea typeface="Calibri" pitchFamily="34" charset="-122"/>
+                <a:cs typeface="Calibri" pitchFamily="34" charset="-120"/>
+              </a:rPr>
+              <a:t>Measured, not hoped: the second file with a known layout costs zero adjudications, asserted in test_correctness_targets_across_the_corpus, not claimed in prose</a:t>
+            </a:r>
+            <a:endParaRPr lang="en-US" sz="900" dirty="0"/>
+          </a:p>
         </p:txBody>
       </p:sp>
       <p:sp>
@@ -28030,11 +28045,11 @@
         <p:spPr>
           <a:xfrm>
             <a:off x="4937760" y="1188720"/>
-            <a:ext cx="3749040" cy="1024128"/>
+            <a:ext cx="3749040" cy="990600"/>
           </a:xfrm>
           <a:prstGeom prst="roundRect">
             <a:avLst>
-              <a:gd name="adj" fmla="val 5357"/>
+              <a:gd name="adj" fmla="val 5538"/>
             </a:avLst>
           </a:prstGeom>
           <a:solidFill>
@@ -28096,7 +28111,7 @@
         <p:spPr>
           <a:xfrm>
             <a:off x="5029200" y="1499616"/>
-            <a:ext cx="3566160" cy="658368"/>
+            <a:ext cx="3566160" cy="624840"/>
           </a:xfrm>
           <a:prstGeom prst="rect">
             <a:avLst/>
@@ -28134,12 +28149,12 @@
         </p:nvSpPr>
         <p:spPr>
           <a:xfrm>
-            <a:off x="4937760" y="2304288"/>
-            <a:ext cx="3749040" cy="1024128"/>
+            <a:off x="4937760" y="2316480"/>
+            <a:ext cx="3749040" cy="990600"/>
           </a:xfrm>
           <a:prstGeom prst="roundRect">
             <a:avLst>
-              <a:gd name="adj" fmla="val 5357"/>
+              <a:gd name="adj" fmla="val 5538"/>
             </a:avLst>
           </a:prstGeom>
           <a:solidFill>
@@ -28161,7 +28176,7 @@
         </p:nvSpPr>
         <p:spPr>
           <a:xfrm>
-            <a:off x="5029200" y="2359152"/>
+            <a:off x="5029200" y="2371344"/>
             <a:ext cx="3566160" cy="256032"/>
           </a:xfrm>
           <a:prstGeom prst="rect">
@@ -28200,8 +28215,8 @@
         </p:nvSpPr>
         <p:spPr>
           <a:xfrm>
-            <a:off x="5029200" y="2615184"/>
-            <a:ext cx="3566160" cy="658368"/>
+            <a:off x="5029200" y="2627376"/>
+            <a:ext cx="3566160" cy="624840"/>
           </a:xfrm>
           <a:prstGeom prst="rect">
             <a:avLst/>
@@ -28239,12 +28254,12 @@
         </p:nvSpPr>
         <p:spPr>
           <a:xfrm>
-            <a:off x="4937760" y="3419856"/>
-            <a:ext cx="3749040" cy="1024128"/>
+            <a:off x="4937760" y="3444240"/>
+            <a:ext cx="3749040" cy="990600"/>
           </a:xfrm>
           <a:prstGeom prst="roundRect">
             <a:avLst>
-              <a:gd name="adj" fmla="val 5357"/>
+              <a:gd name="adj" fmla="val 5538"/>
             </a:avLst>
           </a:prstGeom>
           <a:solidFill>
@@ -28266,7 +28281,7 @@
         </p:nvSpPr>
         <p:spPr>
           <a:xfrm>
-            <a:off x="5029200" y="3474720"/>
+            <a:off x="5029200" y="3499104"/>
             <a:ext cx="3566160" cy="256032"/>
           </a:xfrm>
           <a:prstGeom prst="rect">
@@ -28305,8 +28320,8 @@
         </p:nvSpPr>
         <p:spPr>
           <a:xfrm>
-            <a:off x="5029200" y="3730752"/>
-            <a:ext cx="3566160" cy="658368"/>
+            <a:off x="5029200" y="3755136"/>
+            <a:ext cx="3566160" cy="624840"/>
           </a:xfrm>
           <a:prstGeom prst="rect">
             <a:avLst/>
@@ -28331,111 +28346,6 @@
                 <a:cs typeface="Calibri" pitchFamily="34" charset="-120"/>
               </a:rPr>
               <a:t>a wrong mapping breaks reconciliation silently; unresolved becomes a review item instead</a:t>
-            </a:r>
-            <a:endParaRPr lang="en-US" sz="900" dirty="0"/>
-          </a:p>
-        </p:txBody>
-      </p:sp>
-      <p:sp>
-        <p:nvSpPr>
-          <p:cNvPr id="18" name="Shape 16"/>
-          <p:cNvSpPr/>
-          <p:nvPr/>
-        </p:nvSpPr>
-        <p:spPr>
-          <a:xfrm>
-            <a:off x="4937760" y="3657600"/>
-            <a:ext cx="3749040" cy="777240"/>
-          </a:xfrm>
-          <a:prstGeom prst="roundRect">
-            <a:avLst>
-              <a:gd name="adj" fmla="val 7059"/>
-            </a:avLst>
-          </a:prstGeom>
-          <a:solidFill>
-            <a:srgbClr val="F3F6FA"/>
-          </a:solidFill>
-          <a:ln w="9525">
-            <a:solidFill>
-              <a:srgbClr val="C9D3E0"/>
-            </a:solidFill>
-            <a:prstDash val="solid"/>
-          </a:ln>
-        </p:spPr>
-      </p:sp>
-      <p:sp>
-        <p:nvSpPr>
-          <p:cNvPr id="19" name="Text 17"/>
-          <p:cNvSpPr txBox="1"/>
-          <p:nvPr/>
-        </p:nvSpPr>
-        <p:spPr>
-          <a:xfrm>
-            <a:off x="5029200" y="3712464"/>
-            <a:ext cx="3566160" cy="256032"/>
-          </a:xfrm>
-          <a:prstGeom prst="rect">
-            <a:avLst/>
-          </a:prstGeom>
-          <a:noFill/>
-          <a:ln/>
-        </p:spPr>
-        <p:txBody>
-          <a:bodyPr wrap="square" lIns="0" tIns="0" rIns="0" bIns="0" rtlCol="0" anchor="ctr"/>
-          <a:lstStyle/>
-          <a:p>
-            <a:pPr indent="0" marL="0">
-              <a:buNone/>
-            </a:pPr>
-            <a:r>
-              <a:rPr lang="en-US" sz="1100" b="1" dirty="0">
-                <a:solidFill>
-                  <a:srgbClr val="14213D"/>
-                </a:solidFill>
-                <a:latin typeface="Calibri" pitchFamily="34" charset="0"/>
-                <a:ea typeface="Calibri" pitchFamily="34" charset="-122"/>
-                <a:cs typeface="Calibri" pitchFamily="34" charset="-120"/>
-              </a:rPr>
-              <a:t>Measured, not hoped</a:t>
-            </a:r>
-            <a:endParaRPr lang="en-US" sz="1100" dirty="0"/>
-          </a:p>
-        </p:txBody>
-      </p:sp>
-      <p:sp>
-        <p:nvSpPr>
-          <p:cNvPr id="20" name="Text 18"/>
-          <p:cNvSpPr txBox="1"/>
-          <p:nvPr/>
-        </p:nvSpPr>
-        <p:spPr>
-          <a:xfrm>
-            <a:off x="5029200" y="3968496"/>
-            <a:ext cx="3566160" cy="411480"/>
-          </a:xfrm>
-          <a:prstGeom prst="rect">
-            <a:avLst/>
-          </a:prstGeom>
-          <a:noFill/>
-          <a:ln/>
-        </p:spPr>
-        <p:txBody>
-          <a:bodyPr wrap="square" lIns="0" tIns="0" rIns="0" bIns="0" rtlCol="0" anchor="t"/>
-          <a:lstStyle/>
-          <a:p>
-            <a:pPr indent="0" marL="0">
-              <a:buNone/>
-            </a:pPr>
-            <a:r>
-              <a:rPr lang="en-US" sz="900" dirty="0">
-                <a:solidFill>
-                  <a:srgbClr val="1B2A41"/>
-                </a:solidFill>
-                <a:latin typeface="Calibri" pitchFamily="34" charset="0"/>
-                <a:ea typeface="Calibri" pitchFamily="34" charset="-122"/>
-                <a:cs typeface="Calibri" pitchFamily="34" charset="-120"/>
-              </a:rPr>
-              <a:t>Second file with a known layout costs zero adjudications — asserted in test_correctness_targets_across_the_corpus, not claimed in prose.</a:t>
             </a:r>
             <a:endParaRPr lang="en-US" sz="900" dirty="0"/>
           </a:p>

</xml_diff>